<commit_message>
Update five-slide deck with MIT integration SDK business use cases and current demo
</commit_message>
<xml_diff>
--- a/FINTECH_AI_Demo_Final_5_Slides.pptx
+++ b/FINTECH_AI_Demo_Final_5_Slides.pptx
@@ -506,7 +506,7 @@
           <a:lstStyle/>
           <a:p>
             <a:r>
-              <a:t>0:00–0:45 | Problem and users. We built FINTECH AI for auditors and finance-control teams. Spreadsheets contain many ordinary expenses and a few items worth checking, but a flag alone is not an investigation. Our goal is to put the original record, the screening evidence and the human decision together. We do not claim to detect fraud or replace an auditor. Transition: here is the workflow we implemented.</a:t>
+              <a:t>0:00–0:45 | Good day. We are Digital Surfers and this is FINTECH AI. Finance teams need to find transactions worth checking and record what happens next. This is not just for banks. Ten potential customer categories are retailers, e-commerce businesses, restaurants and hotels, logistics firms, schools, hospitals, NGOs, construction companies, manufacturers, and accounting or audit firms. Examples include supplier invoices, procurement and contractor payments. These are potential use cases, not ten deployed customers. Our initial users are auditors and finance-control teams. We assist investigations, not determine fraud.</a:t>
             </a:r>
           </a:p>
         </p:txBody>
@@ -576,7 +576,7 @@
           <a:lstStyle/>
           <a:p>
             <a:r>
-              <a:t>0:45–1:40 | Workflow. Import a CSV; accepted rows go into SQLite and rejected rows are reported. Screening is deterministic: repeated payment reference, or matching supplier, amount and date. These are possible duplicates, not proven duplicates. Gemma explains supplied evidence only; the server replaces any model-authored observed evidence with authoritative rule evidence before saving. The auditor chooses confirmed, dismissed or needs_review and the API persists the decision, reviewer, notes and time. AI failure does not stop importing or reviewing.</a:t>
+              <a:t>0:45–1:40 | The workflow is import, screen, explain and review. A CSV upload saves accepted transactions and reports rejected rows. Deterministic checks flag repeated references or matching supplier, amount and date. These are possible duplicates, not proof. Gemma interprets the supplied context; the backend preserves server-owned evidence. The auditor confirms, dismisses or selects needs_review. The API stores decision, reviewer, notes and timestamp. Inference failure does not block CSV processing or human review. Re-uploading a file appends data, so do not retry blindly.</a:t>
             </a:r>
           </a:p>
         </p:txBody>
@@ -646,7 +646,7 @@
           <a:lstStyle/>
           <a:p>
             <a:r>
-              <a:t>1:40–2:40 | Technical implementation. Next.js and React call same-origin proxy routes into FastAPI, Pydantic, HTTPX and SQLite. The app is currently configured for Google AI Studio model gemma-4-26b-a4b-it; it is Gemma, not a Gemini substitution. Local Ollama also runs gemma4:latest, a 7.5B Q4 model with roughly 6.6 GB of weights, reachable through the tunnel's /ollama endpoint. Both paths returned successful public requests. Provider selection supports local, cloud and local_then_cloud. Keys stay server-side in ignored .env, not the repo. Three backend tests passed. Separate analysis reports show 100 accepted rows, 6 duplicate rows and 34 anomalies; these are sample outputs, not an accuracy benchmark, and that broader pipeline is not yet called by upload.</a:t>
+              <a:t>1:40–2:40 | Next.js and React proxy requests to FastAPI, Pydantic, HTTPX and SQLite. The application Explain action is configured for Google AI Studio model gemma-4-26b-a4b-it. A separate local Ollama model, gemma4:latest, is 7.5B Q4_K_M with about 6.6 GB of weights. Both inference paths were verified publicly. Local-only, cloud-only and local-then-cloud provider selection are supported. Cloud use sends transaction context and evidence to Google; credentials stay in ignored server-side .env. Seven backend/SDK tests passed, the SDK wheel built and the frontend TypeScript check passed. A separate Pandas/Isolation Forest sample reported 100 accepted rows, 6 possible duplicate rows and 34 anomaly rows; these are sample counts, not a performance benchmark. The full pipeline is not yet invoked by upload.</a:t>
             </a:r>
           </a:p>
         </p:txBody>
@@ -716,7 +716,7 @@
           <a:lstStyle/>
           <a:p>
             <a:r>
-              <a:t>2:40–4:10 | Live demo. Open https://ranks-atlanta-formerly-diverse.trycloudflare.com/dashboard and show the current summary. Upload 01_mixed_office_transactions.csv from demo-data. Go to Anomalies &amp; AI; choose a new office-furniture or maintenance candidate. Show source evidence first, then click Explain to call Google-hosted Gemma. Allow around 35 seconds based on one earlier request, not an SLA. Save a review and refresh. If time permits, upload file 03: expect 16 accepted and 4 rejected for invalid amount, zero, negative and missing date. File 02 is an alternate retail example. Local-model request: POST /ollama/api/generate with JSON {"model":"gemma4:latest","prompt":"Explain duplicate payments briefly.","stream":false,"think":false}. A previous short local response took about 18 seconds; latency varies. Do not upload the same file repeatedly unless deliberately demonstrating repeated imports. If inference fails, show evidence and the review flow rather than claiming the AI succeeded. The tunnel is temporary and scheduled to stop an hour after launch.</a:t>
+              <a:t>2:40–4:10 | Open https://first-reseller-flows-statutes.trycloudflare.com/dashboard. Upload demo-data/01_mixed_office_transactions.csv: 20 valid synthetic office expenses. Open Anomalies &amp; AI and select an office-furniture or maintenance candidate. Show evidence, request Explain, then save a human review and refresh. If the UI lacks a control, use Swagger at https://first-reseller-flows-statutes.trycloudflare.com/backend/docs with an actual finding ID. File 02_mixed_retail_transactions.csv has 20 valid retail rows. File 03_mixed_projects_with_validation.csv has 16 valid and 4 deliberately invalid rows. Files are downloadable under /demo-data/ on the same host. Direct local generation is POST /ollama/api/generate with model gemma4:latest, prompt, stream=false and think=false; it is distinct from persisted audit explanations. Prior short local/cloud requests took roughly 18/35 seconds, not an SLA. If AI is slow, show evidence and saved review instead. Temporary tunnel, unauthenticated synthetic demo only; do not claim this hostname is permanent.</a:t>
             </a:r>
           </a:p>
         </p:txBody>
@@ -786,7 +786,7 @@
           <a:lstStyle/>
           <a:p>
             <a:r>
-              <a:t>4:10–5:00 | Impact, source and next steps. The working deliverable is traceable review, not a measured productivity or fraud-accuracy claim. The public GitHub repo includes the UI, API, broader data pipeline, reports and demo data. An explicit team-approved license is still missing, so be precise: public source today; licensed open-source release is a remaining action. DigitalOcean is a researched self-hosted option, not deployed infrastructure. We would benchmark a 20 GB GPU, run Ollama privately and persist weights for occasional windows; Google-hosted cloud inference already works today. Next: full pipeline adapter, license, access controls and rate limits, then evaluate triage time and review completeness. Close: AI assists; evidence and the auditor decide.</a:t>
+              <a:t>4:10–5:00 | Our deliverable is traceable review, not an unmeasured promise of fraud accuracy or time savings. The code now has an MIT license. Others can clone github.com/kwisdomk/FintechClankerz and install the SDK with pip install ./sdk/python. API version 0.4.0 provides typed OpenAPI 3.1 responses and operation IDs, live Swagger and ReDoc, and an exported docs/openapi.json. docs/INTEGRATION.md has Python, JavaScript and curl examples plus error and CORS guidance; CONTRIBUTING.md supports contributions. Model licenses and hosted-provider terms remain separate. Next: full pipeline hookup, authentication, rate limits, tenant isolation and currency/date hardening. DigitalOcean GPU hosting is researched, not deployed; a 20 GB GPU is a candidate to benchmark. Evaluate triage time and review completeness with users. Close: evidence first, AI assistance second, human judgment always.</a:t>
             </a:r>
           </a:p>
         </p:txBody>
@@ -4396,7 +4396,7 @@
               </a:defRPr>
             </a:pPr>
             <a:r>
-              <a:t>INTENDED USERS</a:t>
+              <a:t>BEYOND BANKS: 10 BUSINESS CATEGORIES</a:t>
             </a:r>
           </a:p>
         </p:txBody>
@@ -4409,7 +4409,7 @@
         </p:nvSpPr>
         <p:spPr>
           <a:xfrm>
-            <a:off x="6492240" y="2697480"/>
+            <a:off x="6492240" y="2651760"/>
             <a:ext cx="201168" cy="274320"/>
           </a:xfrm>
           <a:prstGeom prst="rect">
@@ -4424,7 +4424,7 @@
           <a:lstStyle/>
           <a:p>
             <a:pPr>
-              <a:defRPr sz="1800" b="1">
+              <a:defRPr sz="1600" b="1">
                 <a:solidFill>
                   <a:srgbClr val="3ADCBE"/>
                 </a:solidFill>
@@ -4445,22 +4445,22 @@
         </p:nvSpPr>
         <p:spPr>
           <a:xfrm>
-            <a:off x="6739127" y="2697480"/>
-            <a:ext cx="4370831" cy="822960"/>
-          </a:xfrm>
-          <a:prstGeom prst="rect">
-            <a:avLst/>
-          </a:prstGeom>
-          <a:noFill/>
-        </p:spPr>
-        <p:txBody>
-          <a:bodyPr wrap="square" lIns="18288" rIns="18288" tIns="18288" bIns="18288">
-            <a:spAutoFit/>
-          </a:bodyPr>
-          <a:lstStyle/>
-          <a:p>
-            <a:pPr>
-              <a:defRPr sz="1600" b="0">
+            <a:off x="6739127" y="2651760"/>
+            <a:ext cx="4370831" cy="530352"/>
+          </a:xfrm>
+          <a:prstGeom prst="rect">
+            <a:avLst/>
+          </a:prstGeom>
+          <a:noFill/>
+        </p:spPr>
+        <p:txBody>
+          <a:bodyPr wrap="square" lIns="18288" rIns="18288" tIns="18288" bIns="18288">
+            <a:spAutoFit/>
+          </a:bodyPr>
+          <a:lstStyle/>
+          <a:p>
+            <a:pPr>
+              <a:defRPr sz="1400" b="0">
                 <a:solidFill>
                   <a:srgbClr val="F0F6FA"/>
                 </a:solidFill>
@@ -4468,7 +4468,7 @@
               </a:defRPr>
             </a:pPr>
             <a:r>
-              <a:t>Internal / external auditors</a:t>
+              <a:t>Retail + e-commerce: supplier / fulfilment payments</a:t>
             </a:r>
           </a:p>
         </p:txBody>
@@ -4481,7 +4481,7 @@
         </p:nvSpPr>
         <p:spPr>
           <a:xfrm>
-            <a:off x="6492240" y="3502152"/>
+            <a:off x="6492240" y="3163824"/>
             <a:ext cx="201168" cy="274320"/>
           </a:xfrm>
           <a:prstGeom prst="rect">
@@ -4496,7 +4496,7 @@
           <a:lstStyle/>
           <a:p>
             <a:pPr>
-              <a:defRPr sz="1800" b="1">
+              <a:defRPr sz="1600" b="1">
                 <a:solidFill>
                   <a:srgbClr val="3ADCBE"/>
                 </a:solidFill>
@@ -4517,22 +4517,22 @@
         </p:nvSpPr>
         <p:spPr>
           <a:xfrm>
-            <a:off x="6739127" y="3502152"/>
-            <a:ext cx="4370831" cy="822960"/>
-          </a:xfrm>
-          <a:prstGeom prst="rect">
-            <a:avLst/>
-          </a:prstGeom>
-          <a:noFill/>
-        </p:spPr>
-        <p:txBody>
-          <a:bodyPr wrap="square" lIns="18288" rIns="18288" tIns="18288" bIns="18288">
-            <a:spAutoFit/>
-          </a:bodyPr>
-          <a:lstStyle/>
-          <a:p>
-            <a:pPr>
-              <a:defRPr sz="1600" b="0">
+            <a:off x="6739127" y="3163824"/>
+            <a:ext cx="4370831" cy="530352"/>
+          </a:xfrm>
+          <a:prstGeom prst="rect">
+            <a:avLst/>
+          </a:prstGeom>
+          <a:noFill/>
+        </p:spPr>
+        <p:txBody>
+          <a:bodyPr wrap="square" lIns="18288" rIns="18288" tIns="18288" bIns="18288">
+            <a:spAutoFit/>
+          </a:bodyPr>
+          <a:lstStyle/>
+          <a:p>
+            <a:pPr>
+              <a:defRPr sz="1400" b="0">
                 <a:solidFill>
                   <a:srgbClr val="F0F6FA"/>
                 </a:solidFill>
@@ -4540,7 +4540,7 @@
               </a:defRPr>
             </a:pPr>
             <a:r>
-              <a:t>Finance control and compliance teams</a:t>
+              <a:t>Restaurants / hotels + logistics: operating expenses</a:t>
             </a:r>
           </a:p>
         </p:txBody>
@@ -4553,7 +4553,7 @@
         </p:nvSpPr>
         <p:spPr>
           <a:xfrm>
-            <a:off x="6492240" y="4306824"/>
+            <a:off x="6492240" y="3675887"/>
             <a:ext cx="201168" cy="274320"/>
           </a:xfrm>
           <a:prstGeom prst="rect">
@@ -4568,7 +4568,7 @@
           <a:lstStyle/>
           <a:p>
             <a:pPr>
-              <a:defRPr sz="1800" b="1">
+              <a:defRPr sz="1600" b="1">
                 <a:solidFill>
                   <a:srgbClr val="3ADCBE"/>
                 </a:solidFill>
@@ -4589,22 +4589,22 @@
         </p:nvSpPr>
         <p:spPr>
           <a:xfrm>
-            <a:off x="6739127" y="4306824"/>
-            <a:ext cx="4370831" cy="822960"/>
-          </a:xfrm>
-          <a:prstGeom prst="rect">
-            <a:avLst/>
-          </a:prstGeom>
-          <a:noFill/>
-        </p:spPr>
-        <p:txBody>
-          <a:bodyPr wrap="square" lIns="18288" rIns="18288" tIns="18288" bIns="18288">
-            <a:spAutoFit/>
-          </a:bodyPr>
-          <a:lstStyle/>
-          <a:p>
-            <a:pPr>
-              <a:defRPr sz="1600" b="0">
+            <a:off x="6739127" y="3675887"/>
+            <a:ext cx="4370831" cy="530352"/>
+          </a:xfrm>
+          <a:prstGeom prst="rect">
+            <a:avLst/>
+          </a:prstGeom>
+          <a:noFill/>
+        </p:spPr>
+        <p:txBody>
+          <a:bodyPr wrap="square" lIns="18288" rIns="18288" tIns="18288" bIns="18288">
+            <a:spAutoFit/>
+          </a:bodyPr>
+          <a:lstStyle/>
+          <a:p>
+            <a:pPr>
+              <a:defRPr sz="1400" b="0">
                 <a:solidFill>
                   <a:srgbClr val="F0F6FA"/>
                 </a:solidFill>
@@ -4612,7 +4612,7 @@
               </a:defRPr>
             </a:pPr>
             <a:r>
-              <a:t>Audit leads who need a review trail</a:t>
+              <a:t>Schools + hospitals: procurement invoices</a:t>
             </a:r>
           </a:p>
         </p:txBody>
@@ -4620,6 +4620,186 @@
       <p:sp>
         <p:nvSpPr>
           <p:cNvPr id="24" name="TextBox 23"/>
+          <p:cNvSpPr txBox="1"/>
+          <p:nvPr/>
+        </p:nvSpPr>
+        <p:spPr>
+          <a:xfrm>
+            <a:off x="6492240" y="4187952"/>
+            <a:ext cx="201168" cy="274320"/>
+          </a:xfrm>
+          <a:prstGeom prst="rect">
+            <a:avLst/>
+          </a:prstGeom>
+          <a:noFill/>
+        </p:spPr>
+        <p:txBody>
+          <a:bodyPr wrap="square" lIns="18288" rIns="18288" tIns="18288" bIns="18288">
+            <a:spAutoFit/>
+          </a:bodyPr>
+          <a:lstStyle/>
+          <a:p>
+            <a:pPr>
+              <a:defRPr sz="1600" b="1">
+                <a:solidFill>
+                  <a:srgbClr val="3ADCBE"/>
+                </a:solidFill>
+                <a:latin typeface="Aptos"/>
+              </a:defRPr>
+            </a:pPr>
+            <a:r>
+              <a:t>•</a:t>
+            </a:r>
+          </a:p>
+        </p:txBody>
+      </p:sp>
+      <p:sp>
+        <p:nvSpPr>
+          <p:cNvPr id="25" name="TextBox 24"/>
+          <p:cNvSpPr txBox="1"/>
+          <p:nvPr/>
+        </p:nvSpPr>
+        <p:spPr>
+          <a:xfrm>
+            <a:off x="6739127" y="4187952"/>
+            <a:ext cx="4370831" cy="530352"/>
+          </a:xfrm>
+          <a:prstGeom prst="rect">
+            <a:avLst/>
+          </a:prstGeom>
+          <a:noFill/>
+        </p:spPr>
+        <p:txBody>
+          <a:bodyPr wrap="square" lIns="18288" rIns="18288" tIns="18288" bIns="18288">
+            <a:spAutoFit/>
+          </a:bodyPr>
+          <a:lstStyle/>
+          <a:p>
+            <a:pPr>
+              <a:defRPr sz="1400" b="0">
+                <a:solidFill>
+                  <a:srgbClr val="F0F6FA"/>
+                </a:solidFill>
+                <a:latin typeface="Aptos"/>
+              </a:defRPr>
+            </a:pPr>
+            <a:r>
+              <a:t>NGOs + construction: project / contractor costs</a:t>
+            </a:r>
+          </a:p>
+        </p:txBody>
+      </p:sp>
+      <p:sp>
+        <p:nvSpPr>
+          <p:cNvPr id="26" name="TextBox 25"/>
+          <p:cNvSpPr txBox="1"/>
+          <p:nvPr/>
+        </p:nvSpPr>
+        <p:spPr>
+          <a:xfrm>
+            <a:off x="6492240" y="4700016"/>
+            <a:ext cx="201168" cy="274320"/>
+          </a:xfrm>
+          <a:prstGeom prst="rect">
+            <a:avLst/>
+          </a:prstGeom>
+          <a:noFill/>
+        </p:spPr>
+        <p:txBody>
+          <a:bodyPr wrap="square" lIns="18288" rIns="18288" tIns="18288" bIns="18288">
+            <a:spAutoFit/>
+          </a:bodyPr>
+          <a:lstStyle/>
+          <a:p>
+            <a:pPr>
+              <a:defRPr sz="1600" b="1">
+                <a:solidFill>
+                  <a:srgbClr val="3ADCBE"/>
+                </a:solidFill>
+                <a:latin typeface="Aptos"/>
+              </a:defRPr>
+            </a:pPr>
+            <a:r>
+              <a:t>•</a:t>
+            </a:r>
+          </a:p>
+        </p:txBody>
+      </p:sp>
+      <p:sp>
+        <p:nvSpPr>
+          <p:cNvPr id="27" name="TextBox 26"/>
+          <p:cNvSpPr txBox="1"/>
+          <p:nvPr/>
+        </p:nvSpPr>
+        <p:spPr>
+          <a:xfrm>
+            <a:off x="6739127" y="4700016"/>
+            <a:ext cx="4370831" cy="530352"/>
+          </a:xfrm>
+          <a:prstGeom prst="rect">
+            <a:avLst/>
+          </a:prstGeom>
+          <a:noFill/>
+        </p:spPr>
+        <p:txBody>
+          <a:bodyPr wrap="square" lIns="18288" rIns="18288" tIns="18288" bIns="18288">
+            <a:spAutoFit/>
+          </a:bodyPr>
+          <a:lstStyle/>
+          <a:p>
+            <a:pPr>
+              <a:defRPr sz="1400" b="0">
+                <a:solidFill>
+                  <a:srgbClr val="F0F6FA"/>
+                </a:solidFill>
+                <a:latin typeface="Aptos"/>
+              </a:defRPr>
+            </a:pPr>
+            <a:r>
+              <a:t>Manufacturers + audit firms: vendor / client review</a:t>
+            </a:r>
+          </a:p>
+        </p:txBody>
+      </p:sp>
+      <p:sp>
+        <p:nvSpPr>
+          <p:cNvPr id="28" name="TextBox 27"/>
+          <p:cNvSpPr txBox="1"/>
+          <p:nvPr/>
+        </p:nvSpPr>
+        <p:spPr>
+          <a:xfrm>
+            <a:off x="6519672" y="5312664"/>
+            <a:ext cx="4480560" cy="457200"/>
+          </a:xfrm>
+          <a:prstGeom prst="rect">
+            <a:avLst/>
+          </a:prstGeom>
+          <a:noFill/>
+        </p:spPr>
+        <p:txBody>
+          <a:bodyPr wrap="square" lIns="18288" rIns="18288" tIns="18288" bIns="18288">
+            <a:spAutoFit/>
+          </a:bodyPr>
+          <a:lstStyle/>
+          <a:p>
+            <a:pPr>
+              <a:defRPr sz="1200" b="0">
+                <a:solidFill>
+                  <a:srgbClr val="A4B7C9"/>
+                </a:solidFill>
+                <a:latin typeface="Aptos"/>
+              </a:defRPr>
+            </a:pPr>
+            <a:r>
+              <a:t>Users: auditors, finance-control teams and business owners.</a:t>
+            </a:r>
+          </a:p>
+        </p:txBody>
+      </p:sp>
+      <p:sp>
+        <p:nvSpPr>
+          <p:cNvPr id="29" name="TextBox 28"/>
           <p:cNvSpPr txBox="1"/>
           <p:nvPr/>
         </p:nvSpPr>
@@ -7252,7 +7432,7 @@
               </a:defRPr>
             </a:pPr>
             <a:r>
-              <a:t>3 backend tests passed • public cloud explain + local generation succeeded • separate Pandas / Isolation Forest sample: 100 accepted, 6 duplicate rows, 34 anomaly rows (not yet wired into upload).</a:t>
+              <a:t>7 backend / SDK tests passed • SDK wheel built • frontend TypeScript check passed • cloud + local inference verified. Separate pipeline sample: 100 accepted, 6 duplicate rows, 34 anomalies; full API hookup pending.</a:t>
             </a:r>
           </a:p>
         </p:txBody>
@@ -7429,7 +7609,10 @@
               </a:defRPr>
             </a:pPr>
             <a:r>
-              <a:t>Public app: ranks-atlanta-formerly-diverse.trycloudflare.com/dashboard</a:t>
+              <a:rPr>
+                <a:hlinkClick r:id="rId2"/>
+              </a:rPr>
+              <a:t>Public app: first-reseller-flows-statutes.trycloudflare.com/dashboard</a:t>
             </a:r>
           </a:p>
         </p:txBody>
@@ -8452,7 +8635,7 @@
               </a:defRPr>
             </a:pPr>
             <a:r>
-              <a:t>IMPACT / PUBLIC SOURCE / NEXT STEPS</a:t>
+              <a:t>MIT OPEN SOURCE / INTEGRATION / NEXT STEPS</a:t>
             </a:r>
           </a:p>
         </p:txBody>
@@ -8488,7 +8671,7 @@
               </a:defRPr>
             </a:pPr>
             <a:r>
-              <a:t>Faster triage is the goal. Traceable review is the deliverable.</a:t>
+              <a:t>Built to review payments. Open for others to integrate.</a:t>
             </a:r>
           </a:p>
         </p:txBody>
@@ -8524,7 +8707,7 @@
               </a:defRPr>
             </a:pPr>
             <a:r>
-              <a:t>Value: bring records, candidate findings, AI interpretation and recorded human decisions into one workflow.</a:t>
+              <a:t>Impact target: reduce spreadsheet hunting and improve review traceability; time savings and accuracy are not yet measured.</a:t>
             </a:r>
           </a:p>
         </p:txBody>
@@ -8677,7 +8860,7 @@
               </a:defRPr>
             </a:pPr>
             <a:r>
-              <a:t>DELIVERED &amp; REPRODUCIBLE</a:t>
+              <a:t>DELIVERED: REUSABLE APPLICATION CODE</a:t>
             </a:r>
           </a:p>
         </p:txBody>
@@ -8749,7 +8932,7 @@
               </a:defRPr>
             </a:pPr>
             <a:r>
-              <a:t>github.com/kwisdomk/FintechClankerz — public source; main + mbr-3 synced for demo.</a:t>
+              <a:t>MIT LICENSE • github.com/kwisdomk/FintechClankerz • main + mbr-3.</a:t>
             </a:r>
           </a:p>
         </p:txBody>
@@ -8821,7 +9004,7 @@
               </a:defRPr>
             </a:pPr>
             <a:r>
-              <a:t>Frontend, FastAPI, SQLite, analysis pipeline, tests, reports + synthetic CSVs.</a:t>
+              <a:t>API v0.4.0: typed OpenAPI 3.1 contract, Swagger / ReDoc and stable operation IDs.</a:t>
             </a:r>
           </a:p>
         </p:txBody>
@@ -8893,7 +9076,7 @@
               </a:defRPr>
             </a:pPr>
             <a:r>
-              <a:t>Cloud + local Gemma responses verified; upload and review persist without AI.</a:t>
+              <a:t>Python SDK: pip install ./sdk/python; JavaScript + curl integration examples.</a:t>
             </a:r>
           </a:p>
         </p:txBody>
@@ -8965,7 +9148,7 @@
               </a:defRPr>
             </a:pPr>
             <a:r>
-              <a:t>Measure next: triage time and review completeness versus spreadsheets; no savings claim yet.</a:t>
+              <a:t>docs/INTEGRATION.md • docs/openapi.json • CONTRIBUTING.md • tests + synthetic data.</a:t>
             </a:r>
           </a:p>
         </p:txBody>
@@ -9046,7 +9229,7 @@
               </a:defRPr>
             </a:pPr>
             <a:r>
-              <a:t>LIMITATIONS &amp; NEXT DEPLOYMENT</a:t>
+              <a:t>HONEST LIMITATIONS / WHAT COMES NEXT</a:t>
             </a:r>
           </a:p>
         </p:txBody>
@@ -9118,7 +9301,7 @@
               </a:defRPr>
             </a:pPr>
             <a:r>
-              <a:t>Wire the full Isolation Forest pipeline into the upload API; current live screening is duplicate rules.</a:t>
+              <a:t>Current screening: duplicate rules. Wire full Isolation Forest pipeline into upload next.</a:t>
             </a:r>
           </a:p>
         </p:txBody>
@@ -9190,7 +9373,7 @@
               </a:defRPr>
             </a:pPr>
             <a:r>
-              <a:t>Add team-approved OSS license, access controls, rate limits and provider data policy.</a:t>
+              <a:t>Pre-1.0 MVP: add authentication, rate limits, tenant isolation and robust currency/date handling.</a:t>
             </a:r>
           </a:p>
         </p:txBody>
@@ -9262,7 +9445,7 @@
               </a:defRPr>
             </a:pPr>
             <a:r>
-              <a:t>DigitalOcean GPU + private Ollama: researched, NOT deployed. RTX 4000 Ada 20GB is a candidate to benchmark.</a:t>
+              <a:t>DigitalOcean GPU + private Ollama: researched, NOT deployed. Benchmark a 20GB GPU before committing.</a:t>
             </a:r>
           </a:p>
         </p:txBody>
@@ -9334,7 +9517,7 @@
               </a:defRPr>
             </a:pPr>
             <a:r>
-              <a:t>Demo is temporarily unauthenticated; synthetic records only. Cloud Explain sends evidence to Google.</a:t>
+              <a:t>Synthetic public demo only. Cloud sends evidence to Google; model / provider terms are separate from MIT.</a:t>
             </a:r>
           </a:p>
         </p:txBody>

</xml_diff>